<commit_message>
Fix clinic brand name: Zenith -> Zetith (@zetith_hane)
https://claude.ai/code/session_016Wb6e5A68fyGWAtZg4KdQn
</commit_message>
<xml_diff>
--- a/鼻整形_症例カタログ.pptx
+++ b/鼻整形_症例カタログ.pptx
@@ -3686,7 +3686,7 @@
                 <a:latin typeface="游ゴシック"/>
                 <a:ea typeface="游ゴシック"/>
               </a:rPr>
-              <a:t>Zenith Beauty Clinic Fukuoka</a:t>
+              <a:t>Zetith Beauty Clinic Fukuoka</a:t>
             </a:r>
           </a:p>
         </p:txBody>
@@ -4773,7 +4773,7 @@
                 <a:latin typeface="游ゴシック"/>
                 <a:ea typeface="游ゴシック"/>
               </a:rPr>
-              <a:t>Zenith Beauty Clinic</a:t>
+              <a:t>Zetith Beauty Clinic</a:t>
             </a:r>
           </a:p>
         </p:txBody>
@@ -5884,7 +5884,7 @@
                 <a:latin typeface="游ゴシック"/>
                 <a:ea typeface="游ゴシック"/>
               </a:rPr>
-              <a:t>Zenith Beauty Clinic</a:t>
+              <a:t>Zetith Beauty Clinic</a:t>
             </a:r>
           </a:p>
         </p:txBody>
@@ -7062,7 +7062,7 @@
                 <a:latin typeface="游明朝"/>
                 <a:ea typeface="游明朝"/>
               </a:rPr>
-              <a:t>@zenith_hane</a:t>
+              <a:t>@zetith_hane</a:t>
             </a:r>
           </a:p>
           <a:p>
@@ -7108,7 +7108,7 @@
                 <a:latin typeface="游ゴシック"/>
                 <a:ea typeface="游ゴシック"/>
               </a:rPr>
-              <a:t>Zenith Beauty Clinic Fukuoka</a:t>
+              <a:t>Zetith Beauty Clinic Fukuoka</a:t>
             </a:r>
           </a:p>
           <a:p>
@@ -7566,7 +7566,7 @@
                 <a:latin typeface="游ゴシック"/>
                 <a:ea typeface="游ゴシック"/>
               </a:rPr>
-              <a:t>Zenith Beauty Clinic</a:t>
+              <a:t>Zetith Beauty Clinic</a:t>
             </a:r>
           </a:p>
         </p:txBody>
@@ -9003,7 +9003,7 @@
                 <a:latin typeface="游ゴシック"/>
                 <a:ea typeface="游ゴシック"/>
               </a:rPr>
-              <a:t>Zenith Beauty Clinic</a:t>
+              <a:t>Zetith Beauty Clinic</a:t>
             </a:r>
           </a:p>
         </p:txBody>
@@ -10563,7 +10563,7 @@
                 <a:latin typeface="游ゴシック"/>
                 <a:ea typeface="游ゴシック"/>
               </a:rPr>
-              <a:t>Zenith Beauty Clinic</a:t>
+              <a:t>Zetith Beauty Clinic</a:t>
             </a:r>
           </a:p>
         </p:txBody>
@@ -12857,7 +12857,7 @@
                 <a:latin typeface="游ゴシック"/>
                 <a:ea typeface="游ゴシック"/>
               </a:rPr>
-              <a:t>Zenith Beauty Clinic</a:t>
+              <a:t>Zetith Beauty Clinic</a:t>
             </a:r>
           </a:p>
         </p:txBody>
@@ -15151,7 +15151,7 @@
                 <a:latin typeface="游ゴシック"/>
                 <a:ea typeface="游ゴシック"/>
               </a:rPr>
-              <a:t>Zenith Beauty Clinic</a:t>
+              <a:t>Zetith Beauty Clinic</a:t>
             </a:r>
           </a:p>
         </p:txBody>
@@ -17445,7 +17445,7 @@
                 <a:latin typeface="游ゴシック"/>
                 <a:ea typeface="游ゴシック"/>
               </a:rPr>
-              <a:t>Zenith Beauty Clinic</a:t>
+              <a:t>Zetith Beauty Clinic</a:t>
             </a:r>
           </a:p>
         </p:txBody>
@@ -19739,7 +19739,7 @@
                 <a:latin typeface="游ゴシック"/>
                 <a:ea typeface="游ゴシック"/>
               </a:rPr>
-              <a:t>Zenith Beauty Clinic</a:t>
+              <a:t>Zetith Beauty Clinic</a:t>
             </a:r>
           </a:p>
         </p:txBody>
@@ -22033,7 +22033,7 @@
                 <a:latin typeface="游ゴシック"/>
                 <a:ea typeface="游ゴシック"/>
               </a:rPr>
-              <a:t>Zenith Beauty Clinic</a:t>
+              <a:t>Zetith Beauty Clinic</a:t>
             </a:r>
           </a:p>
         </p:txBody>
@@ -24327,7 +24327,7 @@
                 <a:latin typeface="游ゴシック"/>
                 <a:ea typeface="游ゴシック"/>
               </a:rPr>
-              <a:t>Zenith Beauty Clinic</a:t>
+              <a:t>Zetith Beauty Clinic</a:t>
             </a:r>
           </a:p>
         </p:txBody>

</xml_diff>